<commit_message>
feat: update subscription pricing to 20-25k KZT across presentation and analytical docs
</commit_message>
<xml_diff>
--- a/RestoKZ_Presentation.pptx
+++ b/RestoKZ_Presentation.pptx
@@ -5152,7 +5152,7 @@
                         </a:defRPr>
                       </a:pPr>
                       <a:r>
-                        <a:t>✅ Фиксир. 35–49 тыс ₸</a:t>
+                        <a:t>✅ Фиксир. 20–25 тыс ₸</a:t>
                       </a:r>
                     </a:p>
                   </a:txBody>
@@ -6360,7 +6360,7 @@
               </a:defRPr>
             </a:pPr>
             <a:r>
-              <a:t>Формула 1:1 — окупается всего за 1 спасенный банкетный стол на 8-10 человек в месяц</a:t>
+              <a:t>Формула 1:1 — окупается всего за 1 спасенный стол в месяц (чек от 25 000 ₸)</a:t>
             </a:r>
           </a:p>
         </p:txBody>
@@ -6455,7 +6455,7 @@
               </a:defRPr>
             </a:pPr>
             <a:r>
-              <a:t>35 000 ₸</a:t>
+              <a:t>20 000 ₸</a:t>
             </a:r>
           </a:p>
           <a:p>
@@ -6640,7 +6640,7 @@
               </a:defRPr>
             </a:pPr>
             <a:r>
-              <a:t>49 000 ₸</a:t>
+              <a:t>25 000 ₸</a:t>
             </a:r>
           </a:p>
           <a:p>
@@ -6840,7 +6840,7 @@
               </a:defRPr>
             </a:pPr>
             <a:r>
-              <a:t>65 000 ₸</a:t>
+              <a:t>35 000 ₸</a:t>
             </a:r>
           </a:p>
           <a:p>
@@ -8058,7 +8058,7 @@
               </a:defRPr>
             </a:pPr>
             <a:r>
-              <a:t>Тариф 49 000 ₸ окупается за 1 спасенный банкетный стол в месяц. Очевидный ROI.</a:t>
+              <a:t>Тариф 25 000 ₸ окупается всего за 1 спасенный стол в месяц. Очевидный ROI.</a:t>
             </a:r>
           </a:p>
           <a:p>
@@ -9591,7 +9591,7 @@
                         </a:defRPr>
                       </a:pPr>
                       <a:r>
-                        <a:t>Согласны на 49к₸: окупается за 1 банкетный стол</a:t>
+                        <a:t>Согласны на 20–25к₸: окупается за 1 спасенный стол</a:t>
                       </a:r>
                     </a:p>
                   </a:txBody>

</xml_diff>

<commit_message>
fix: straighten and realign presentation mockups, clean unclipped screenshots, and refine captions
</commit_message>
<xml_diff>
--- a/RestoKZ_Presentation.pptx
+++ b/RestoKZ_Presentation.pptx
@@ -3541,54 +3541,9 @@
           </a:p>
         </p:txBody>
       </p:sp>
-      <p:sp>
-        <p:nvSpPr>
-          <p:cNvPr id="11" name="Rounded Rectangle 10"/>
-          <p:cNvSpPr/>
-          <p:nvPr/>
-        </p:nvSpPr>
-        <p:spPr>
-          <a:xfrm>
-            <a:off x="8375904" y="1060704"/>
-            <a:ext cx="2313432" cy="4919472"/>
-          </a:xfrm>
-          <a:prstGeom prst="roundRect">
-            <a:avLst/>
-          </a:prstGeom>
-          <a:solidFill>
-            <a:srgbClr val="1A1E27"/>
-          </a:solidFill>
-          <a:ln w="19050">
-            <a:solidFill>
-              <a:srgbClr val="C5A880"/>
-            </a:solidFill>
-          </a:ln>
-        </p:spPr>
-        <p:style>
-          <a:lnRef idx="1">
-            <a:schemeClr val="accent1"/>
-          </a:lnRef>
-          <a:fillRef idx="3">
-            <a:schemeClr val="accent1"/>
-          </a:fillRef>
-          <a:effectRef idx="2">
-            <a:schemeClr val="accent1"/>
-          </a:effectRef>
-          <a:fontRef idx="minor">
-            <a:schemeClr val="lt1"/>
-          </a:fontRef>
-        </p:style>
-        <p:txBody>
-          <a:bodyPr rtlCol="0" anchor="ctr"/>
-          <a:lstStyle/>
-          <a:p>
-            <a:pPr algn="ctr"/>
-          </a:p>
-        </p:txBody>
-      </p:sp>
       <p:pic>
         <p:nvPicPr>
-          <p:cNvPr id="12" name="Picture 11" descr="admin_terminal_mobile.png"/>
+          <p:cNvPr id="11" name="Picture 10" descr="hero_dual_mockup.png"/>
           <p:cNvPicPr>
             <a:picLocks noChangeAspect="1"/>
           </p:cNvPicPr>
@@ -3602,77 +3557,8 @@
         </p:blipFill>
         <p:spPr>
           <a:xfrm>
-            <a:off x="8412480" y="1097280"/>
-            <a:ext cx="2240280" cy="4846320"/>
-          </a:xfrm>
-          <a:prstGeom prst="rect">
-            <a:avLst/>
-          </a:prstGeom>
-        </p:spPr>
-      </p:pic>
-      <p:sp>
-        <p:nvSpPr>
-          <p:cNvPr id="13" name="Rounded Rectangle 12"/>
-          <p:cNvSpPr/>
-          <p:nvPr/>
-        </p:nvSpPr>
-        <p:spPr>
-          <a:xfrm>
-            <a:off x="9747504" y="1517904"/>
-            <a:ext cx="2084832" cy="4370832"/>
-          </a:xfrm>
-          <a:prstGeom prst="roundRect">
-            <a:avLst/>
-          </a:prstGeom>
-          <a:solidFill>
-            <a:srgbClr val="1A1E27"/>
-          </a:solidFill>
-          <a:ln w="19050">
-            <a:solidFill>
-              <a:srgbClr val="C5A880"/>
-            </a:solidFill>
-          </a:ln>
-        </p:spPr>
-        <p:style>
-          <a:lnRef idx="1">
-            <a:schemeClr val="accent1"/>
-          </a:lnRef>
-          <a:fillRef idx="3">
-            <a:schemeClr val="accent1"/>
-          </a:fillRef>
-          <a:effectRef idx="2">
-            <a:schemeClr val="accent1"/>
-          </a:effectRef>
-          <a:fontRef idx="minor">
-            <a:schemeClr val="lt1"/>
-          </a:fontRef>
-        </p:style>
-        <p:txBody>
-          <a:bodyPr rtlCol="0" anchor="ctr"/>
-          <a:lstStyle/>
-          <a:p>
-            <a:pPr algn="ctr"/>
-          </a:p>
-        </p:txBody>
-      </p:sp>
-      <p:pic>
-        <p:nvPicPr>
-          <p:cNvPr id="14" name="Picture 13" descr="guest_catalog_mobile.png"/>
-          <p:cNvPicPr>
-            <a:picLocks noChangeAspect="1"/>
-          </p:cNvPicPr>
-          <p:nvPr/>
-        </p:nvPicPr>
-        <p:blipFill>
-          <a:blip r:embed="rId3"/>
-          <a:stretch>
-            <a:fillRect/>
-          </a:stretch>
-        </p:blipFill>
-        <p:spPr>
-          <a:xfrm>
-            <a:off x="9784080" y="1554480"/>
-            <a:ext cx="2011680" cy="4297680"/>
+            <a:off x="7132320" y="1051560"/>
+            <a:ext cx="4572000" cy="4718304"/>
           </a:xfrm>
           <a:prstGeom prst="rect">
             <a:avLst/>

</xml_diff>

<commit_message>
feat: replace mentality hypothesis with professional zoning and walk-in reservation hypothesis
</commit_message>
<xml_diff>
--- a/RestoKZ_Presentation.pptx
+++ b/RestoKZ_Presentation.pptx
@@ -5343,7 +5343,7 @@
                         </a:defRPr>
                       </a:pPr>
                       <a:r>
-                        <a:t>Учет менталитета</a:t>
+                        <a:t>Зонирование зала и Walk-in</a:t>
                       </a:r>
                     </a:p>
                   </a:txBody>
@@ -5389,7 +5389,7 @@
                         </a:defRPr>
                       </a:pPr>
                       <a:r>
-                        <a:t>❌ Без топчанов и VIP</a:t>
+                        <a:t>❌ Сложный ввод, нет зон</a:t>
                       </a:r>
                     </a:p>
                   </a:txBody>
@@ -5412,7 +5412,7 @@
                         </a:defRPr>
                       </a:pPr>
                       <a:r>
-                        <a:t>❌ Шаблоны под РФ</a:t>
+                        <a:t>❌ Без интерактивных зон</a:t>
                       </a:r>
                     </a:p>
                   </a:txBody>
@@ -5435,7 +5435,7 @@
                         </a:defRPr>
                       </a:pPr>
                       <a:r>
-                        <a:t>❌ Сложно для персонала</a:t>
+                        <a:t>❌ Нет учета посадки</a:t>
                       </a:r>
                     </a:p>
                   </a:txBody>
@@ -5458,7 +5458,7 @@
                         </a:defRPr>
                       </a:pPr>
                       <a:r>
-                        <a:t>👑 100% ('По звонку', VIP)</a:t>
+                        <a:t>👑 100% (Карта зон + Walk-in)</a:t>
                       </a:r>
                     </a:p>
                   </a:txBody>
@@ -7974,7 +7974,7 @@
               </a:defRPr>
             </a:pPr>
             <a:r>
-              <a:t>Учет менталитета Казахстана (топчаны, VIP, язык, звонки Баке) защищает от глобальных гигантов.</a:t>
+              <a:t>Глубокая адаптация под процессы заведений Казахстана (Walk-in, зонирование VIP, RU/KZ/EN) защищает от глобальных гигантов.</a:t>
             </a:r>
           </a:p>
           <a:p>
@@ -9298,11 +9298,11 @@
                         </a:defRPr>
                       </a:pPr>
                       <a:r>
-                        <a:t>H4: Менталитет</a:t>
+                        <a:t>H4: Зонирование и</a:t>
                       </a:r>
                       <a:br/>
                       <a:r>
-                        <a:t>(топчан и Баке)</a:t>
+                        <a:t>Walk-in (от двери)</a:t>
                       </a:r>
                     </a:p>
                   </a:txBody>
@@ -9352,7 +9352,7 @@
                         </a:defRPr>
                       </a:pPr>
                       <a:r>
-                        <a:t>Важность зон (топчан, кабина) и звонков директору</a:t>
+                        <a:t>Важность выбора зон (VIP, окно, терраса) и быстрой записи звонков</a:t>
                       </a:r>
                     </a:p>
                   </a:txBody>
@@ -9375,7 +9375,7 @@
                         </a:defRPr>
                       </a:pPr>
                       <a:r>
-                        <a:t>2 молодежные кофейни («у нас европейский формат, без топчанов и агашек»)</a:t>
+                        <a:t>2 заведения fast-casual («у нас живая очередь без броней и без разделения на зоны»)</a:t>
                       </a:r>
                     </a:p>
                   </a:txBody>
@@ -9398,7 +9398,7 @@
                         </a:defRPr>
                       </a:pPr>
                       <a:r>
-                        <a:t>Зонирование зала + кнопка брони «По звонку» за 3 секунды</a:t>
+                        <a:t>Интерактивная карта зон зала + кнопка посадки «Walk-in / По звонку» за 3 сек</a:t>
                       </a:r>
                     </a:p>
                   </a:txBody>

</xml_diff>